<commit_message>
Implement persistent backend database, synchronized patient records, and architecture documentation
</commit_message>
<xml_diff>
--- a/documentation/Skin_Cancer_Detection_Project_Presentation.pptx
+++ b/documentation/Skin_Cancer_Detection_Project_Presentation.pptx
@@ -5,20 +5,22 @@
     <p:sldMasterId id="2147483648" r:id="rId1"/>
   </p:sldMasterIdLst>
   <p:sldIdLst>
-    <p:sldId id="256" r:id="rId7"/>
-    <p:sldId id="257" r:id="rId8"/>
-    <p:sldId id="258" r:id="rId9"/>
-    <p:sldId id="259" r:id="rId10"/>
-    <p:sldId id="260" r:id="rId11"/>
-    <p:sldId id="261" r:id="rId12"/>
-    <p:sldId id="262" r:id="rId13"/>
-    <p:sldId id="263" r:id="rId14"/>
-    <p:sldId id="264" r:id="rId15"/>
-    <p:sldId id="265" r:id="rId16"/>
-    <p:sldId id="266" r:id="rId17"/>
-    <p:sldId id="267" r:id="rId18"/>
+    <p:sldId id="256" r:id="rId2"/>
+    <p:sldId id="257" r:id="rId3"/>
+    <p:sldId id="258" r:id="rId4"/>
+    <p:sldId id="259" r:id="rId5"/>
+    <p:sldId id="260" r:id="rId6"/>
+    <p:sldId id="261" r:id="rId7"/>
+    <p:sldId id="262" r:id="rId8"/>
+    <p:sldId id="263" r:id="rId9"/>
+    <p:sldId id="264" r:id="rId10"/>
+    <p:sldId id="265" r:id="rId11"/>
+    <p:sldId id="266" r:id="rId12"/>
+    <p:sldId id="267" r:id="rId13"/>
+    <p:sldId id="269" r:id="rId14"/>
+    <p:sldId id="271" r:id="rId15"/>
   </p:sldIdLst>
-  <p:sldSz cx="12191695" cy="6858000" type="screen4x3"/>
+  <p:sldSz cx="12192000" cy="6858000"/>
   <p:notesSz cx="6858000" cy="9144000"/>
   <p:defaultTextStyle>
     <a:defPPr>
@@ -115,6 +117,22 @@
       </a:defRPr>
     </a:lvl9pPr>
   </p:defaultTextStyle>
+  <p:extLst>
+    <p:ext uri="{EFAFB233-063F-42B5-8137-9DF3F51BA10A}">
+      <p15:sldGuideLst xmlns:p15="http://schemas.microsoft.com/office/powerpoint/2012/main">
+        <p15:guide id="1" orient="horz" pos="2160">
+          <p15:clr>
+            <a:srgbClr val="A4A3A4"/>
+          </p15:clr>
+        </p15:guide>
+        <p15:guide id="2" pos="2880">
+          <p15:clr>
+            <a:srgbClr val="A4A3A4"/>
+          </p15:clr>
+        </p15:guide>
+      </p15:sldGuideLst>
+    </p:ext>
+  </p:extLst>
 </p:presentation>
 </file>
 
@@ -156,10 +174,9 @@
           <a:lstStyle/>
           <a:p>
             <a:r>
-              <a:rPr lang="en-US" smtClean="0"/>
+              <a:rPr lang="en-US"/>
               <a:t>Click to edit Master title style</a:t>
             </a:r>
-            <a:endParaRPr lang="en-US"/>
           </a:p>
         </p:txBody>
       </p:sp>
@@ -275,10 +292,9 @@
           </a:lstStyle>
           <a:p>
             <a:r>
-              <a:rPr lang="en-US" smtClean="0"/>
+              <a:rPr lang="en-US"/>
               <a:t>Click to edit Master subtitle style</a:t>
             </a:r>
-            <a:endParaRPr lang="en-US"/>
           </a:p>
         </p:txBody>
       </p:sp>
@@ -299,7 +315,7 @@
           <a:p>
             <a:fld id="{5BCAD085-E8A6-8845-BD4E-CB4CCA059FC4}" type="datetimeFigureOut">
               <a:rPr lang="en-US" smtClean="0"/>
-              <a:t>1/27/13</a:t>
+              <a:t>10/25/2026</a:t>
             </a:fld>
             <a:endParaRPr lang="en-US"/>
           </a:p>
@@ -393,10 +409,9 @@
           <a:lstStyle/>
           <a:p>
             <a:r>
-              <a:rPr lang="en-US" smtClean="0"/>
+              <a:rPr lang="en-US"/>
               <a:t>Click to edit Master title style</a:t>
             </a:r>
-            <a:endParaRPr lang="en-US"/>
           </a:p>
         </p:txBody>
       </p:sp>
@@ -417,38 +432,37 @@
           <a:p>
             <a:pPr lvl="0"/>
             <a:r>
-              <a:rPr lang="en-US" smtClean="0"/>
+              <a:rPr lang="en-US"/>
               <a:t>Click to edit Master text styles</a:t>
             </a:r>
           </a:p>
           <a:p>
             <a:pPr lvl="1"/>
             <a:r>
-              <a:rPr lang="en-US" smtClean="0"/>
+              <a:rPr lang="en-US"/>
               <a:t>Second level</a:t>
             </a:r>
           </a:p>
           <a:p>
             <a:pPr lvl="2"/>
             <a:r>
-              <a:rPr lang="en-US" smtClean="0"/>
+              <a:rPr lang="en-US"/>
               <a:t>Third level</a:t>
             </a:r>
           </a:p>
           <a:p>
             <a:pPr lvl="3"/>
             <a:r>
-              <a:rPr lang="en-US" smtClean="0"/>
+              <a:rPr lang="en-US"/>
               <a:t>Fourth level</a:t>
             </a:r>
           </a:p>
           <a:p>
             <a:pPr lvl="4"/>
             <a:r>
-              <a:rPr lang="en-US" smtClean="0"/>
+              <a:rPr lang="en-US"/>
               <a:t>Fifth level</a:t>
             </a:r>
-            <a:endParaRPr lang="en-US"/>
           </a:p>
         </p:txBody>
       </p:sp>
@@ -469,7 +483,7 @@
           <a:p>
             <a:fld id="{5BCAD085-E8A6-8845-BD4E-CB4CCA059FC4}" type="datetimeFigureOut">
               <a:rPr lang="en-US" smtClean="0"/>
-              <a:t>1/27/13</a:t>
+              <a:t>10/25/2026</a:t>
             </a:fld>
             <a:endParaRPr lang="en-US"/>
           </a:p>
@@ -568,10 +582,9 @@
           <a:lstStyle/>
           <a:p>
             <a:r>
-              <a:rPr lang="en-US" smtClean="0"/>
+              <a:rPr lang="en-US"/>
               <a:t>Click to edit Master title style</a:t>
             </a:r>
-            <a:endParaRPr lang="en-US"/>
           </a:p>
         </p:txBody>
       </p:sp>
@@ -597,38 +610,37 @@
           <a:p>
             <a:pPr lvl="0"/>
             <a:r>
-              <a:rPr lang="en-US" smtClean="0"/>
+              <a:rPr lang="en-US"/>
               <a:t>Click to edit Master text styles</a:t>
             </a:r>
           </a:p>
           <a:p>
             <a:pPr lvl="1"/>
             <a:r>
-              <a:rPr lang="en-US" smtClean="0"/>
+              <a:rPr lang="en-US"/>
               <a:t>Second level</a:t>
             </a:r>
           </a:p>
           <a:p>
             <a:pPr lvl="2"/>
             <a:r>
-              <a:rPr lang="en-US" smtClean="0"/>
+              <a:rPr lang="en-US"/>
               <a:t>Third level</a:t>
             </a:r>
           </a:p>
           <a:p>
             <a:pPr lvl="3"/>
             <a:r>
-              <a:rPr lang="en-US" smtClean="0"/>
+              <a:rPr lang="en-US"/>
               <a:t>Fourth level</a:t>
             </a:r>
           </a:p>
           <a:p>
             <a:pPr lvl="4"/>
             <a:r>
-              <a:rPr lang="en-US" smtClean="0"/>
+              <a:rPr lang="en-US"/>
               <a:t>Fifth level</a:t>
             </a:r>
-            <a:endParaRPr lang="en-US"/>
           </a:p>
         </p:txBody>
       </p:sp>
@@ -649,7 +661,7 @@
           <a:p>
             <a:fld id="{5BCAD085-E8A6-8845-BD4E-CB4CCA059FC4}" type="datetimeFigureOut">
               <a:rPr lang="en-US" smtClean="0"/>
-              <a:t>1/27/13</a:t>
+              <a:t>10/25/2026</a:t>
             </a:fld>
             <a:endParaRPr lang="en-US"/>
           </a:p>
@@ -743,10 +755,9 @@
           <a:lstStyle/>
           <a:p>
             <a:r>
-              <a:rPr lang="en-US" smtClean="0"/>
+              <a:rPr lang="en-US"/>
               <a:t>Click to edit Master title style</a:t>
             </a:r>
-            <a:endParaRPr lang="en-US"/>
           </a:p>
         </p:txBody>
       </p:sp>
@@ -767,38 +778,37 @@
           <a:p>
             <a:pPr lvl="0"/>
             <a:r>
-              <a:rPr lang="en-US" smtClean="0"/>
+              <a:rPr lang="en-US"/>
               <a:t>Click to edit Master text styles</a:t>
             </a:r>
           </a:p>
           <a:p>
             <a:pPr lvl="1"/>
             <a:r>
-              <a:rPr lang="en-US" smtClean="0"/>
+              <a:rPr lang="en-US"/>
               <a:t>Second level</a:t>
             </a:r>
           </a:p>
           <a:p>
             <a:pPr lvl="2"/>
             <a:r>
-              <a:rPr lang="en-US" smtClean="0"/>
+              <a:rPr lang="en-US"/>
               <a:t>Third level</a:t>
             </a:r>
           </a:p>
           <a:p>
             <a:pPr lvl="3"/>
             <a:r>
-              <a:rPr lang="en-US" smtClean="0"/>
+              <a:rPr lang="en-US"/>
               <a:t>Fourth level</a:t>
             </a:r>
           </a:p>
           <a:p>
             <a:pPr lvl="4"/>
             <a:r>
-              <a:rPr lang="en-US" smtClean="0"/>
+              <a:rPr lang="en-US"/>
               <a:t>Fifth level</a:t>
             </a:r>
-            <a:endParaRPr lang="en-US"/>
           </a:p>
         </p:txBody>
       </p:sp>
@@ -819,7 +829,7 @@
           <a:p>
             <a:fld id="{5BCAD085-E8A6-8845-BD4E-CB4CCA059FC4}" type="datetimeFigureOut">
               <a:rPr lang="en-US" smtClean="0"/>
-              <a:t>1/27/13</a:t>
+              <a:t>10/25/2026</a:t>
             </a:fld>
             <a:endParaRPr lang="en-US"/>
           </a:p>
@@ -922,10 +932,9 @@
           </a:lstStyle>
           <a:p>
             <a:r>
-              <a:rPr lang="en-US" smtClean="0"/>
+              <a:rPr lang="en-US"/>
               <a:t>Click to edit Master title style</a:t>
             </a:r>
-            <a:endParaRPr lang="en-US"/>
           </a:p>
         </p:txBody>
       </p:sp>
@@ -1042,7 +1051,7 @@
           <a:p>
             <a:pPr lvl="0"/>
             <a:r>
-              <a:rPr lang="en-US" smtClean="0"/>
+              <a:rPr lang="en-US"/>
               <a:t>Click to edit Master text styles</a:t>
             </a:r>
           </a:p>
@@ -1065,7 +1074,7 @@
           <a:p>
             <a:fld id="{5BCAD085-E8A6-8845-BD4E-CB4CCA059FC4}" type="datetimeFigureOut">
               <a:rPr lang="en-US" smtClean="0"/>
-              <a:t>1/27/13</a:t>
+              <a:t>10/25/2026</a:t>
             </a:fld>
             <a:endParaRPr lang="en-US"/>
           </a:p>
@@ -1159,10 +1168,9 @@
           <a:lstStyle/>
           <a:p>
             <a:r>
-              <a:rPr lang="en-US" smtClean="0"/>
+              <a:rPr lang="en-US"/>
               <a:t>Click to edit Master title style</a:t>
             </a:r>
-            <a:endParaRPr lang="en-US"/>
           </a:p>
         </p:txBody>
       </p:sp>
@@ -1216,38 +1224,37 @@
           <a:p>
             <a:pPr lvl="0"/>
             <a:r>
-              <a:rPr lang="en-US" smtClean="0"/>
+              <a:rPr lang="en-US"/>
               <a:t>Click to edit Master text styles</a:t>
             </a:r>
           </a:p>
           <a:p>
             <a:pPr lvl="1"/>
             <a:r>
-              <a:rPr lang="en-US" smtClean="0"/>
+              <a:rPr lang="en-US"/>
               <a:t>Second level</a:t>
             </a:r>
           </a:p>
           <a:p>
             <a:pPr lvl="2"/>
             <a:r>
-              <a:rPr lang="en-US" smtClean="0"/>
+              <a:rPr lang="en-US"/>
               <a:t>Third level</a:t>
             </a:r>
           </a:p>
           <a:p>
             <a:pPr lvl="3"/>
             <a:r>
-              <a:rPr lang="en-US" smtClean="0"/>
+              <a:rPr lang="en-US"/>
               <a:t>Fourth level</a:t>
             </a:r>
           </a:p>
           <a:p>
             <a:pPr lvl="4"/>
             <a:r>
-              <a:rPr lang="en-US" smtClean="0"/>
+              <a:rPr lang="en-US"/>
               <a:t>Fifth level</a:t>
             </a:r>
-            <a:endParaRPr lang="en-US"/>
           </a:p>
         </p:txBody>
       </p:sp>
@@ -1301,38 +1308,37 @@
           <a:p>
             <a:pPr lvl="0"/>
             <a:r>
-              <a:rPr lang="en-US" smtClean="0"/>
+              <a:rPr lang="en-US"/>
               <a:t>Click to edit Master text styles</a:t>
             </a:r>
           </a:p>
           <a:p>
             <a:pPr lvl="1"/>
             <a:r>
-              <a:rPr lang="en-US" smtClean="0"/>
+              <a:rPr lang="en-US"/>
               <a:t>Second level</a:t>
             </a:r>
           </a:p>
           <a:p>
             <a:pPr lvl="2"/>
             <a:r>
-              <a:rPr lang="en-US" smtClean="0"/>
+              <a:rPr lang="en-US"/>
               <a:t>Third level</a:t>
             </a:r>
           </a:p>
           <a:p>
             <a:pPr lvl="3"/>
             <a:r>
-              <a:rPr lang="en-US" smtClean="0"/>
+              <a:rPr lang="en-US"/>
               <a:t>Fourth level</a:t>
             </a:r>
           </a:p>
           <a:p>
             <a:pPr lvl="4"/>
             <a:r>
-              <a:rPr lang="en-US" smtClean="0"/>
+              <a:rPr lang="en-US"/>
               <a:t>Fifth level</a:t>
             </a:r>
-            <a:endParaRPr lang="en-US"/>
           </a:p>
         </p:txBody>
       </p:sp>
@@ -1353,7 +1359,7 @@
           <a:p>
             <a:fld id="{5BCAD085-E8A6-8845-BD4E-CB4CCA059FC4}" type="datetimeFigureOut">
               <a:rPr lang="en-US" smtClean="0"/>
-              <a:t>1/27/13</a:t>
+              <a:t>10/25/2026</a:t>
             </a:fld>
             <a:endParaRPr lang="en-US"/>
           </a:p>
@@ -1451,10 +1457,9 @@
           </a:lstStyle>
           <a:p>
             <a:r>
-              <a:rPr lang="en-US" smtClean="0"/>
+              <a:rPr lang="en-US"/>
               <a:t>Click to edit Master title style</a:t>
             </a:r>
-            <a:endParaRPr lang="en-US"/>
           </a:p>
         </p:txBody>
       </p:sp>
@@ -1517,7 +1522,7 @@
           <a:p>
             <a:pPr lvl="0"/>
             <a:r>
-              <a:rPr lang="en-US" smtClean="0"/>
+              <a:rPr lang="en-US"/>
               <a:t>Click to edit Master text styles</a:t>
             </a:r>
           </a:p>
@@ -1573,38 +1578,37 @@
           <a:p>
             <a:pPr lvl="0"/>
             <a:r>
-              <a:rPr lang="en-US" smtClean="0"/>
+              <a:rPr lang="en-US"/>
               <a:t>Click to edit Master text styles</a:t>
             </a:r>
           </a:p>
           <a:p>
             <a:pPr lvl="1"/>
             <a:r>
-              <a:rPr lang="en-US" smtClean="0"/>
+              <a:rPr lang="en-US"/>
               <a:t>Second level</a:t>
             </a:r>
           </a:p>
           <a:p>
             <a:pPr lvl="2"/>
             <a:r>
-              <a:rPr lang="en-US" smtClean="0"/>
+              <a:rPr lang="en-US"/>
               <a:t>Third level</a:t>
             </a:r>
           </a:p>
           <a:p>
             <a:pPr lvl="3"/>
             <a:r>
-              <a:rPr lang="en-US" smtClean="0"/>
+              <a:rPr lang="en-US"/>
               <a:t>Fourth level</a:t>
             </a:r>
           </a:p>
           <a:p>
             <a:pPr lvl="4"/>
             <a:r>
-              <a:rPr lang="en-US" smtClean="0"/>
+              <a:rPr lang="en-US"/>
               <a:t>Fifth level</a:t>
             </a:r>
-            <a:endParaRPr lang="en-US"/>
           </a:p>
         </p:txBody>
       </p:sp>
@@ -1667,7 +1671,7 @@
           <a:p>
             <a:pPr lvl="0"/>
             <a:r>
-              <a:rPr lang="en-US" smtClean="0"/>
+              <a:rPr lang="en-US"/>
               <a:t>Click to edit Master text styles</a:t>
             </a:r>
           </a:p>
@@ -1723,38 +1727,37 @@
           <a:p>
             <a:pPr lvl="0"/>
             <a:r>
-              <a:rPr lang="en-US" smtClean="0"/>
+              <a:rPr lang="en-US"/>
               <a:t>Click to edit Master text styles</a:t>
             </a:r>
           </a:p>
           <a:p>
             <a:pPr lvl="1"/>
             <a:r>
-              <a:rPr lang="en-US" smtClean="0"/>
+              <a:rPr lang="en-US"/>
               <a:t>Second level</a:t>
             </a:r>
           </a:p>
           <a:p>
             <a:pPr lvl="2"/>
             <a:r>
-              <a:rPr lang="en-US" smtClean="0"/>
+              <a:rPr lang="en-US"/>
               <a:t>Third level</a:t>
             </a:r>
           </a:p>
           <a:p>
             <a:pPr lvl="3"/>
             <a:r>
-              <a:rPr lang="en-US" smtClean="0"/>
+              <a:rPr lang="en-US"/>
               <a:t>Fourth level</a:t>
             </a:r>
           </a:p>
           <a:p>
             <a:pPr lvl="4"/>
             <a:r>
-              <a:rPr lang="en-US" smtClean="0"/>
+              <a:rPr lang="en-US"/>
               <a:t>Fifth level</a:t>
             </a:r>
-            <a:endParaRPr lang="en-US"/>
           </a:p>
         </p:txBody>
       </p:sp>
@@ -1775,7 +1778,7 @@
           <a:p>
             <a:fld id="{5BCAD085-E8A6-8845-BD4E-CB4CCA059FC4}" type="datetimeFigureOut">
               <a:rPr lang="en-US" smtClean="0"/>
-              <a:t>1/27/13</a:t>
+              <a:t>10/25/2026</a:t>
             </a:fld>
             <a:endParaRPr lang="en-US"/>
           </a:p>
@@ -1869,10 +1872,9 @@
           <a:lstStyle/>
           <a:p>
             <a:r>
-              <a:rPr lang="en-US" smtClean="0"/>
+              <a:rPr lang="en-US"/>
               <a:t>Click to edit Master title style</a:t>
             </a:r>
-            <a:endParaRPr lang="en-US"/>
           </a:p>
         </p:txBody>
       </p:sp>
@@ -1893,7 +1895,7 @@
           <a:p>
             <a:fld id="{5BCAD085-E8A6-8845-BD4E-CB4CCA059FC4}" type="datetimeFigureOut">
               <a:rPr lang="en-US" smtClean="0"/>
-              <a:t>1/27/13</a:t>
+              <a:t>10/25/2026</a:t>
             </a:fld>
             <a:endParaRPr lang="en-US"/>
           </a:p>
@@ -1988,7 +1990,7 @@
           <a:p>
             <a:fld id="{5BCAD085-E8A6-8845-BD4E-CB4CCA059FC4}" type="datetimeFigureOut">
               <a:rPr lang="en-US" smtClean="0"/>
-              <a:t>1/27/13</a:t>
+              <a:t>10/25/2026</a:t>
             </a:fld>
             <a:endParaRPr lang="en-US"/>
           </a:p>
@@ -2091,10 +2093,9 @@
           </a:lstStyle>
           <a:p>
             <a:r>
-              <a:rPr lang="en-US" smtClean="0"/>
+              <a:rPr lang="en-US"/>
               <a:t>Click to edit Master title style</a:t>
             </a:r>
-            <a:endParaRPr lang="en-US"/>
           </a:p>
         </p:txBody>
       </p:sp>
@@ -2148,38 +2149,37 @@
           <a:p>
             <a:pPr lvl="0"/>
             <a:r>
-              <a:rPr lang="en-US" smtClean="0"/>
+              <a:rPr lang="en-US"/>
               <a:t>Click to edit Master text styles</a:t>
             </a:r>
           </a:p>
           <a:p>
             <a:pPr lvl="1"/>
             <a:r>
-              <a:rPr lang="en-US" smtClean="0"/>
+              <a:rPr lang="en-US"/>
               <a:t>Second level</a:t>
             </a:r>
           </a:p>
           <a:p>
             <a:pPr lvl="2"/>
             <a:r>
-              <a:rPr lang="en-US" smtClean="0"/>
+              <a:rPr lang="en-US"/>
               <a:t>Third level</a:t>
             </a:r>
           </a:p>
           <a:p>
             <a:pPr lvl="3"/>
             <a:r>
-              <a:rPr lang="en-US" smtClean="0"/>
+              <a:rPr lang="en-US"/>
               <a:t>Fourth level</a:t>
             </a:r>
           </a:p>
           <a:p>
             <a:pPr lvl="4"/>
             <a:r>
-              <a:rPr lang="en-US" smtClean="0"/>
+              <a:rPr lang="en-US"/>
               <a:t>Fifth level</a:t>
             </a:r>
-            <a:endParaRPr lang="en-US"/>
           </a:p>
         </p:txBody>
       </p:sp>
@@ -2242,7 +2242,7 @@
           <a:p>
             <a:pPr lvl="0"/>
             <a:r>
-              <a:rPr lang="en-US" smtClean="0"/>
+              <a:rPr lang="en-US"/>
               <a:t>Click to edit Master text styles</a:t>
             </a:r>
           </a:p>
@@ -2265,7 +2265,7 @@
           <a:p>
             <a:fld id="{5BCAD085-E8A6-8845-BD4E-CB4CCA059FC4}" type="datetimeFigureOut">
               <a:rPr lang="en-US" smtClean="0"/>
-              <a:t>1/27/13</a:t>
+              <a:t>10/25/2026</a:t>
             </a:fld>
             <a:endParaRPr lang="en-US"/>
           </a:p>
@@ -2368,10 +2368,9 @@
           </a:lstStyle>
           <a:p>
             <a:r>
-              <a:rPr lang="en-US" smtClean="0"/>
+              <a:rPr lang="en-US"/>
               <a:t>Click to edit Master title style</a:t>
             </a:r>
-            <a:endParaRPr lang="en-US"/>
           </a:p>
         </p:txBody>
       </p:sp>
@@ -2495,7 +2494,7 @@
           <a:p>
             <a:pPr lvl="0"/>
             <a:r>
-              <a:rPr lang="en-US" smtClean="0"/>
+              <a:rPr lang="en-US"/>
               <a:t>Click to edit Master text styles</a:t>
             </a:r>
           </a:p>
@@ -2518,7 +2517,7 @@
           <a:p>
             <a:fld id="{5BCAD085-E8A6-8845-BD4E-CB4CCA059FC4}" type="datetimeFigureOut">
               <a:rPr lang="en-US" smtClean="0"/>
-              <a:t>1/27/13</a:t>
+              <a:t>10/25/2026</a:t>
             </a:fld>
             <a:endParaRPr lang="en-US"/>
           </a:p>
@@ -2627,10 +2626,9 @@
           <a:lstStyle/>
           <a:p>
             <a:r>
-              <a:rPr lang="en-US" smtClean="0"/>
+              <a:rPr lang="en-US"/>
               <a:t>Click to edit Master title style</a:t>
             </a:r>
-            <a:endParaRPr lang="en-US"/>
           </a:p>
         </p:txBody>
       </p:sp>
@@ -2661,38 +2659,37 @@
           <a:p>
             <a:pPr lvl="0"/>
             <a:r>
-              <a:rPr lang="en-US" smtClean="0"/>
+              <a:rPr lang="en-US"/>
               <a:t>Click to edit Master text styles</a:t>
             </a:r>
           </a:p>
           <a:p>
             <a:pPr lvl="1"/>
             <a:r>
-              <a:rPr lang="en-US" smtClean="0"/>
+              <a:rPr lang="en-US"/>
               <a:t>Second level</a:t>
             </a:r>
           </a:p>
           <a:p>
             <a:pPr lvl="2"/>
             <a:r>
-              <a:rPr lang="en-US" smtClean="0"/>
+              <a:rPr lang="en-US"/>
               <a:t>Third level</a:t>
             </a:r>
           </a:p>
           <a:p>
             <a:pPr lvl="3"/>
             <a:r>
-              <a:rPr lang="en-US" smtClean="0"/>
+              <a:rPr lang="en-US"/>
               <a:t>Fourth level</a:t>
             </a:r>
           </a:p>
           <a:p>
             <a:pPr lvl="4"/>
             <a:r>
-              <a:rPr lang="en-US" smtClean="0"/>
+              <a:rPr lang="en-US"/>
               <a:t>Fifth level</a:t>
             </a:r>
-            <a:endParaRPr lang="en-US"/>
           </a:p>
         </p:txBody>
       </p:sp>
@@ -2731,7 +2728,7 @@
           <a:p>
             <a:fld id="{5BCAD085-E8A6-8845-BD4E-CB4CCA059FC4}" type="datetimeFigureOut">
               <a:rPr lang="en-US" smtClean="0"/>
-              <a:t>1/27/13</a:t>
+              <a:t>10/25/2026</a:t>
             </a:fld>
             <a:endParaRPr lang="en-US"/>
           </a:p>
@@ -3090,7 +3087,7 @@
 </file>
 
 <file path=ppt/slides/slide1.xml><?xml version="1.0" encoding="utf-8"?>
-<p:sld xmlns:a="http://schemas.openxmlformats.org/drawingml/2006/main" xmlns:p="http://schemas.openxmlformats.org/presentationml/2006/main" xmlns:r="http://schemas.openxmlformats.org/officeDocument/2006/relationships">
+<p:sld xmlns:a="http://schemas.openxmlformats.org/drawingml/2006/main" xmlns:r="http://schemas.openxmlformats.org/officeDocument/2006/relationships" xmlns:p="http://schemas.openxmlformats.org/presentationml/2006/main">
   <p:cSld>
     <p:bg>
       <p:bgPr>
@@ -3106,7 +3103,14 @@
         <p:cNvGrpSpPr/>
         <p:nvPr/>
       </p:nvGrpSpPr>
-      <p:grpSpPr/>
+      <p:grpSpPr>
+        <a:xfrm>
+          <a:off x="0" y="0"/>
+          <a:ext cx="0" cy="0"/>
+          <a:chOff x="0" y="0"/>
+          <a:chExt cx="0" cy="0"/>
+        </a:xfrm>
+      </p:grpSpPr>
       <p:sp>
         <p:nvSpPr>
           <p:cNvPr id="2" name="TextBox 1"/>
@@ -3217,7 +3221,7 @@
 </file>
 
 <file path=ppt/slides/slide10.xml><?xml version="1.0" encoding="utf-8"?>
-<p:sld xmlns:a="http://schemas.openxmlformats.org/drawingml/2006/main" xmlns:p="http://schemas.openxmlformats.org/presentationml/2006/main" xmlns:r="http://schemas.openxmlformats.org/officeDocument/2006/relationships">
+<p:sld xmlns:a="http://schemas.openxmlformats.org/drawingml/2006/main" xmlns:r="http://schemas.openxmlformats.org/officeDocument/2006/relationships" xmlns:p="http://schemas.openxmlformats.org/presentationml/2006/main">
   <p:cSld>
     <p:bg>
       <p:bgPr>
@@ -3233,7 +3237,14 @@
         <p:cNvGrpSpPr/>
         <p:nvPr/>
       </p:nvGrpSpPr>
-      <p:grpSpPr/>
+      <p:grpSpPr>
+        <a:xfrm>
+          <a:off x="0" y="0"/>
+          <a:ext cx="0" cy="0"/>
+          <a:chOff x="0" y="0"/>
+          <a:chExt cx="0" cy="0"/>
+        </a:xfrm>
+      </p:grpSpPr>
       <p:sp>
         <p:nvSpPr>
           <p:cNvPr id="2" name="TextBox 1"/>
@@ -3325,13 +3336,15 @@
             <a:spAutoFit/>
           </a:bodyPr>
           <a:lstStyle/>
-          <a:p/>
+          <a:p>
+            <a:endParaRPr/>
+          </a:p>
           <a:p>
             <a:pPr>
               <a:spcAft>
                 <a:spcPts val="1200"/>
               </a:spcAft>
-              <a:defRPr b="1" sz="1400">
+              <a:defRPr sz="1400" b="1">
                 <a:solidFill>
                   <a:srgbClr val="493F3A"/>
                 </a:solidFill>
@@ -3341,7 +3354,7 @@
               <a:t>•  Presentation Demo Member Account: </a:t>
             </a:r>
             <a:r>
-              <a:rPr b="0" sz="1300"/>
+              <a:rPr sz="1300" b="0"/>
               <a:t>Full Name: Bhavi Doshi | Username: bhavi12 | Email: bhavidoshi12@gmail.com | Password: Bhavi@2026! (Role: Patient).</a:t>
             </a:r>
           </a:p>
@@ -3350,7 +3363,7 @@
               <a:spcAft>
                 <a:spcPts val="1200"/>
               </a:spcAft>
-              <a:defRPr b="1" sz="1400">
+              <a:defRPr sz="1400" b="1">
                 <a:solidFill>
                   <a:srgbClr val="493F3A"/>
                 </a:solidFill>
@@ -3360,7 +3373,7 @@
               <a:t>•  System Administrator Account: </a:t>
             </a:r>
             <a:r>
-              <a:rPr b="0" sz="1300"/>
+              <a:rPr sz="1300" b="0"/>
               <a:t>Full Name: System Administrator | Username: admin | Email: admin@dermacare.ai | Password: Admin@2026!Demo (Role: Admin).</a:t>
             </a:r>
           </a:p>
@@ -3369,7 +3382,7 @@
               <a:spcAft>
                 <a:spcPts val="1200"/>
               </a:spcAft>
-              <a:defRPr b="1" sz="1400">
+              <a:defRPr sz="1400" b="1">
                 <a:solidFill>
                   <a:srgbClr val="493F3A"/>
                 </a:solidFill>
@@ -3379,7 +3392,7 @@
               <a:t>•  Member Flow Demonstrated: </a:t>
             </a:r>
             <a:r>
-              <a:rPr b="0" sz="1300"/>
+              <a:rPr sz="1300" b="0"/>
               <a:t>Sign in via username/email -&gt; User Dashboard with preloaded history -&gt; Upload dermoscopic image -&gt; Real-time 7-class prediction &amp; risk badge -&gt; Instant PDF report download.</a:t>
             </a:r>
           </a:p>
@@ -3388,7 +3401,7 @@
               <a:spcAft>
                 <a:spcPts val="1200"/>
               </a:spcAft>
-              <a:defRPr b="1" sz="1400">
+              <a:defRPr sz="1400" b="1">
                 <a:solidFill>
                   <a:srgbClr val="493F3A"/>
                 </a:solidFill>
@@ -3398,7 +3411,7 @@
               <a:t>•  Administrator Flow Demonstrated: </a:t>
             </a:r>
             <a:r>
-              <a:rPr b="0" sz="1300"/>
+              <a:rPr sz="1300" b="0"/>
               <a:t>Sign in as Admin -&gt; Access /admin console -&gt; Inspect model telemetry, database metrics, read-only user roster, and global screening surveillance.</a:t>
             </a:r>
           </a:p>
@@ -3413,7 +3426,7 @@
 </file>
 
 <file path=ppt/slides/slide11.xml><?xml version="1.0" encoding="utf-8"?>
-<p:sld xmlns:a="http://schemas.openxmlformats.org/drawingml/2006/main" xmlns:p="http://schemas.openxmlformats.org/presentationml/2006/main" xmlns:r="http://schemas.openxmlformats.org/officeDocument/2006/relationships">
+<p:sld xmlns:a="http://schemas.openxmlformats.org/drawingml/2006/main" xmlns:r="http://schemas.openxmlformats.org/officeDocument/2006/relationships" xmlns:p="http://schemas.openxmlformats.org/presentationml/2006/main">
   <p:cSld>
     <p:bg>
       <p:bgPr>
@@ -3429,7 +3442,14 @@
         <p:cNvGrpSpPr/>
         <p:nvPr/>
       </p:nvGrpSpPr>
-      <p:grpSpPr/>
+      <p:grpSpPr>
+        <a:xfrm>
+          <a:off x="0" y="0"/>
+          <a:ext cx="0" cy="0"/>
+          <a:chOff x="0" y="0"/>
+          <a:chExt cx="0" cy="0"/>
+        </a:xfrm>
+      </p:grpSpPr>
       <p:sp>
         <p:nvSpPr>
           <p:cNvPr id="2" name="TextBox 1"/>
@@ -3521,13 +3541,15 @@
             <a:spAutoFit/>
           </a:bodyPr>
           <a:lstStyle/>
-          <a:p/>
+          <a:p>
+            <a:endParaRPr/>
+          </a:p>
           <a:p>
             <a:pPr>
               <a:spcAft>
                 <a:spcPts val="1200"/>
               </a:spcAft>
-              <a:defRPr b="1" sz="1400">
+              <a:defRPr sz="1400" b="1">
                 <a:solidFill>
                   <a:srgbClr val="493F3A"/>
                 </a:solidFill>
@@ -3537,7 +3559,7 @@
               <a:t>•  Current Limitations: </a:t>
             </a:r>
             <a:r>
-              <a:rPr b="0" sz="1300"/>
+              <a:rPr sz="1300" b="0"/>
               <a:t>Model trained on a subset to respect CPU hardware constraints; uses 2D dermoscopic imagery without clinical patient metadata (age, sex, anatomical site); not clinically certified.</a:t>
             </a:r>
           </a:p>
@@ -3546,7 +3568,7 @@
               <a:spcAft>
                 <a:spcPts val="1200"/>
               </a:spcAft>
-              <a:defRPr b="1" sz="1400">
+              <a:defRPr sz="1400" b="1">
                 <a:solidFill>
                   <a:srgbClr val="493F3A"/>
                 </a:solidFill>
@@ -3556,7 +3578,7 @@
               <a:t>•  Dataset Scaling &amp; GPU Training: </a:t>
             </a:r>
             <a:r>
-              <a:rPr b="0" sz="1300"/>
+              <a:rPr sz="1300" b="0"/>
               <a:t>Scale model training across the full 10,015 HAM10000 images using GPU cloud instances (AWS/GCP) with cosine decay learning rates.</a:t>
             </a:r>
           </a:p>
@@ -3565,7 +3587,7 @@
               <a:spcAft>
                 <a:spcPts val="1200"/>
               </a:spcAft>
-              <a:defRPr b="1" sz="1400">
+              <a:defRPr sz="1400" b="1">
                 <a:solidFill>
                   <a:srgbClr val="493F3A"/>
                 </a:solidFill>
@@ -3575,7 +3597,7 @@
               <a:t>•  Explainable AI (XAI) Integration: </a:t>
             </a:r>
             <a:r>
-              <a:rPr b="0" sz="1300"/>
+              <a:rPr sz="1300" b="0"/>
               <a:t>Incorporate Grad-CAM (Gradient-weighted Class Activation Mapping) heatmaps to visually highlight the exact lesion regions influencing neural decisions.</a:t>
             </a:r>
           </a:p>
@@ -3584,7 +3606,7 @@
               <a:spcAft>
                 <a:spcPts val="1200"/>
               </a:spcAft>
-              <a:defRPr b="1" sz="1400">
+              <a:defRPr sz="1400" b="1">
                 <a:solidFill>
                   <a:srgbClr val="493F3A"/>
                 </a:solidFill>
@@ -3594,7 +3616,7 @@
               <a:t>•  Multi-Modal Clinical Fusion: </a:t>
             </a:r>
             <a:r>
-              <a:rPr b="0" sz="1300"/>
+              <a:rPr sz="1300" b="0"/>
               <a:t>Combine patient demographic features (age, gender, anatomical location) alongside deep visual feature embeddings for enhanced diagnostic sensitivity.</a:t>
             </a:r>
           </a:p>
@@ -3609,7 +3631,7 @@
 </file>
 
 <file path=ppt/slides/slide12.xml><?xml version="1.0" encoding="utf-8"?>
-<p:sld xmlns:a="http://schemas.openxmlformats.org/drawingml/2006/main" xmlns:p="http://schemas.openxmlformats.org/presentationml/2006/main" xmlns:r="http://schemas.openxmlformats.org/officeDocument/2006/relationships">
+<p:sld xmlns:a="http://schemas.openxmlformats.org/drawingml/2006/main" xmlns:r="http://schemas.openxmlformats.org/officeDocument/2006/relationships" xmlns:p="http://schemas.openxmlformats.org/presentationml/2006/main">
   <p:cSld>
     <p:bg>
       <p:bgPr>
@@ -3625,7 +3647,14 @@
         <p:cNvGrpSpPr/>
         <p:nvPr/>
       </p:nvGrpSpPr>
-      <p:grpSpPr/>
+      <p:grpSpPr>
+        <a:xfrm>
+          <a:off x="0" y="0"/>
+          <a:ext cx="0" cy="0"/>
+          <a:chOff x="0" y="0"/>
+          <a:chExt cx="0" cy="0"/>
+        </a:xfrm>
+      </p:grpSpPr>
       <p:sp>
         <p:nvSpPr>
           <p:cNvPr id="2" name="TextBox 1"/>
@@ -3719,7 +3748,7 @@
           <a:lstStyle/>
           <a:p>
             <a:pPr>
-              <a:defRPr b="1" sz="1500">
+              <a:defRPr sz="1500" b="1">
                 <a:solidFill>
                   <a:srgbClr val="4A6B53"/>
                 </a:solidFill>
@@ -3754,7 +3783,7 @@
           </a:p>
           <a:p>
             <a:pPr>
-              <a:defRPr b="1" sz="1500">
+              <a:defRPr sz="1500" b="1">
                 <a:solidFill>
                   <a:srgbClr val="B86B77"/>
                 </a:solidFill>
@@ -3834,8 +3863,564 @@
 </p:sld>
 </file>
 
+<file path=ppt/slides/slide13.xml><?xml version="1.0" encoding="utf-8"?>
+<p:sld xmlns:a="http://schemas.openxmlformats.org/drawingml/2006/main" xmlns:r="http://schemas.openxmlformats.org/officeDocument/2006/relationships" xmlns:p="http://schemas.openxmlformats.org/presentationml/2006/main">
+  <p:cSld>
+    <p:bg>
+      <p:bgPr>
+        <a:solidFill>
+          <a:srgbClr val="FFF9F3"/>
+        </a:solidFill>
+        <a:effectLst/>
+      </p:bgPr>
+    </p:bg>
+    <p:spTree>
+      <p:nvGrpSpPr>
+        <p:cNvPr id="1" name="">
+          <a:extLst>
+            <a:ext uri="{FF2B5EF4-FFF2-40B4-BE49-F238E27FC236}">
+              <a16:creationId xmlns:a16="http://schemas.microsoft.com/office/drawing/2014/main" id="{4F26ECAA-F87B-D71E-971A-D0AF77F4AC7C}"/>
+            </a:ext>
+          </a:extLst>
+        </p:cNvPr>
+        <p:cNvGrpSpPr/>
+        <p:nvPr/>
+      </p:nvGrpSpPr>
+      <p:grpSpPr>
+        <a:xfrm>
+          <a:off x="0" y="0"/>
+          <a:ext cx="0" cy="0"/>
+          <a:chOff x="0" y="0"/>
+          <a:chExt cx="0" cy="0"/>
+        </a:xfrm>
+      </p:grpSpPr>
+      <p:sp>
+        <p:nvSpPr>
+          <p:cNvPr id="2" name="TextBox 1">
+            <a:extLst>
+              <a:ext uri="{FF2B5EF4-FFF2-40B4-BE49-F238E27FC236}">
+                <a16:creationId xmlns:a16="http://schemas.microsoft.com/office/drawing/2014/main" id="{F5ABF67E-0F7E-CD27-EEDA-6F1F43305C45}"/>
+              </a:ext>
+            </a:extLst>
+          </p:cNvPr>
+          <p:cNvSpPr txBox="1"/>
+          <p:nvPr/>
+        </p:nvSpPr>
+        <p:spPr>
+          <a:xfrm>
+            <a:off x="731520" y="365760"/>
+            <a:ext cx="10698480" cy="365760"/>
+          </a:xfrm>
+          <a:prstGeom prst="rect">
+            <a:avLst/>
+          </a:prstGeom>
+          <a:noFill/>
+        </p:spPr>
+        <p:txBody>
+          <a:bodyPr wrap="none">
+            <a:spAutoFit/>
+          </a:bodyPr>
+          <a:lstStyle/>
+          <a:p>
+            <a:pPr marL="0" marR="0" lvl="0" indent="0" algn="l" defTabSz="457200" rtl="0" eaLnBrk="1" fontAlgn="auto" latinLnBrk="0" hangingPunct="1">
+              <a:lnSpc>
+                <a:spcPct val="100000"/>
+              </a:lnSpc>
+              <a:spcBef>
+                <a:spcPts val="0"/>
+              </a:spcBef>
+              <a:spcAft>
+                <a:spcPts val="0"/>
+              </a:spcAft>
+              <a:buClrTx/>
+              <a:buSzTx/>
+              <a:buFontTx/>
+              <a:buNone/>
+              <a:tabLst/>
+              <a:defRPr sz="1000" b="1">
+                <a:solidFill>
+                  <a:srgbClr val="B86B77"/>
+                </a:solidFill>
+              </a:defRPr>
+            </a:pPr>
+            <a:r>
+              <a:rPr kumimoji="0" sz="1000" b="1" i="0" u="none" strike="noStrike" kern="1200" cap="none" spc="0" normalizeH="0" baseline="0" noProof="0">
+                <a:ln>
+                  <a:noFill/>
+                </a:ln>
+                <a:solidFill>
+                  <a:srgbClr val="B86B77"/>
+                </a:solidFill>
+                <a:effectLst/>
+                <a:uLnTx/>
+                <a:uFillTx/>
+                <a:latin typeface="Calibri"/>
+                <a:ea typeface="+mn-ea"/>
+                <a:cs typeface="+mn-cs"/>
+              </a:rPr>
+              <a:t>SOFTWARE ENGINEERING MINI-PROJECT</a:t>
+            </a:r>
+          </a:p>
+        </p:txBody>
+      </p:sp>
+      <p:sp>
+        <p:nvSpPr>
+          <p:cNvPr id="3" name="TextBox 2">
+            <a:extLst>
+              <a:ext uri="{FF2B5EF4-FFF2-40B4-BE49-F238E27FC236}">
+                <a16:creationId xmlns:a16="http://schemas.microsoft.com/office/drawing/2014/main" id="{FAF87ECE-C099-BE5C-F7A9-46BA569EB120}"/>
+              </a:ext>
+            </a:extLst>
+          </p:cNvPr>
+          <p:cNvSpPr txBox="1"/>
+          <p:nvPr/>
+        </p:nvSpPr>
+        <p:spPr>
+          <a:xfrm>
+            <a:off x="731520" y="640080"/>
+            <a:ext cx="10698480" cy="731520"/>
+          </a:xfrm>
+          <a:prstGeom prst="rect">
+            <a:avLst/>
+          </a:prstGeom>
+          <a:noFill/>
+        </p:spPr>
+        <p:txBody>
+          <a:bodyPr wrap="none">
+            <a:spAutoFit/>
+          </a:bodyPr>
+          <a:lstStyle/>
+          <a:p>
+            <a:pPr marL="0" marR="0" lvl="0" indent="0" algn="l" defTabSz="457200" rtl="0" eaLnBrk="1" fontAlgn="auto" latinLnBrk="0" hangingPunct="1">
+              <a:lnSpc>
+                <a:spcPct val="100000"/>
+              </a:lnSpc>
+              <a:spcBef>
+                <a:spcPts val="0"/>
+              </a:spcBef>
+              <a:spcAft>
+                <a:spcPts val="0"/>
+              </a:spcAft>
+              <a:buClrTx/>
+              <a:buSzTx/>
+              <a:buFontTx/>
+              <a:buNone/>
+              <a:tabLst/>
+              <a:defRPr sz="2400" b="1">
+                <a:solidFill>
+                  <a:srgbClr val="493F3A"/>
+                </a:solidFill>
+              </a:defRPr>
+            </a:pPr>
+            <a:r>
+              <a:rPr kumimoji="0" sz="2400" b="1" i="0" u="none" strike="noStrike" kern="1200" cap="none" spc="0" normalizeH="0" baseline="0" noProof="0">
+                <a:ln>
+                  <a:noFill/>
+                </a:ln>
+                <a:solidFill>
+                  <a:srgbClr val="493F3A"/>
+                </a:solidFill>
+                <a:effectLst/>
+                <a:uLnTx/>
+                <a:uFillTx/>
+                <a:latin typeface="Calibri"/>
+                <a:ea typeface="+mn-ea"/>
+                <a:cs typeface="+mn-cs"/>
+              </a:rPr>
+              <a:t>Conclusion &amp; Academic References</a:t>
+            </a:r>
+          </a:p>
+        </p:txBody>
+      </p:sp>
+      <p:sp>
+        <p:nvSpPr>
+          <p:cNvPr id="4" name="TextBox 3">
+            <a:extLst>
+              <a:ext uri="{FF2B5EF4-FFF2-40B4-BE49-F238E27FC236}">
+                <a16:creationId xmlns:a16="http://schemas.microsoft.com/office/drawing/2014/main" id="{73027234-A141-6862-2D51-8143D34F7A7B}"/>
+              </a:ext>
+            </a:extLst>
+          </p:cNvPr>
+          <p:cNvSpPr txBox="1"/>
+          <p:nvPr/>
+        </p:nvSpPr>
+        <p:spPr>
+          <a:xfrm>
+            <a:off x="458142" y="1737360"/>
+            <a:ext cx="10698480" cy="261610"/>
+          </a:xfrm>
+          <a:prstGeom prst="rect">
+            <a:avLst/>
+          </a:prstGeom>
+          <a:noFill/>
+        </p:spPr>
+        <p:txBody>
+          <a:bodyPr wrap="square">
+            <a:spAutoFit/>
+          </a:bodyPr>
+          <a:lstStyle/>
+          <a:p>
+            <a:pPr marL="0" marR="0" lvl="0" indent="0" algn="l" defTabSz="457200" rtl="0" eaLnBrk="1" fontAlgn="auto" latinLnBrk="0" hangingPunct="1">
+              <a:lnSpc>
+                <a:spcPct val="100000"/>
+              </a:lnSpc>
+              <a:spcBef>
+                <a:spcPts val="0"/>
+              </a:spcBef>
+              <a:spcAft>
+                <a:spcPts val="0"/>
+              </a:spcAft>
+              <a:buClrTx/>
+              <a:buSzTx/>
+              <a:buFontTx/>
+              <a:buNone/>
+              <a:tabLst/>
+              <a:defRPr sz="1500" b="1">
+                <a:solidFill>
+                  <a:srgbClr val="4A6B53"/>
+                </a:solidFill>
+              </a:defRPr>
+            </a:pPr>
+            <a:endParaRPr kumimoji="0" sz="1100" b="0" i="0" u="none" strike="noStrike" kern="1200" cap="none" spc="0" normalizeH="0" baseline="0" noProof="0" dirty="0">
+              <a:ln>
+                <a:noFill/>
+              </a:ln>
+              <a:solidFill>
+                <a:srgbClr val="493F3A"/>
+              </a:solidFill>
+              <a:effectLst/>
+              <a:uLnTx/>
+              <a:uFillTx/>
+              <a:latin typeface="Calibri"/>
+              <a:ea typeface="+mn-ea"/>
+              <a:cs typeface="+mn-cs"/>
+            </a:endParaRPr>
+          </a:p>
+        </p:txBody>
+      </p:sp>
+      <p:pic>
+        <p:nvPicPr>
+          <p:cNvPr id="6" name="Picture 5">
+            <a:extLst>
+              <a:ext uri="{FF2B5EF4-FFF2-40B4-BE49-F238E27FC236}">
+                <a16:creationId xmlns:a16="http://schemas.microsoft.com/office/drawing/2014/main" id="{1A77B290-E65A-DCCF-F88C-E9E93028EFA9}"/>
+              </a:ext>
+            </a:extLst>
+          </p:cNvPr>
+          <p:cNvPicPr>
+            <a:picLocks noChangeAspect="1"/>
+          </p:cNvPicPr>
+          <p:nvPr/>
+        </p:nvPicPr>
+        <p:blipFill>
+          <a:blip r:embed="rId2"/>
+          <a:stretch>
+            <a:fillRect/>
+          </a:stretch>
+        </p:blipFill>
+        <p:spPr>
+          <a:xfrm>
+            <a:off x="2552393" y="2124623"/>
+            <a:ext cx="7087214" cy="1760373"/>
+          </a:xfrm>
+          <a:prstGeom prst="rect">
+            <a:avLst/>
+          </a:prstGeom>
+        </p:spPr>
+      </p:pic>
+    </p:spTree>
+    <p:extLst>
+      <p:ext uri="{BB962C8B-B14F-4D97-AF65-F5344CB8AC3E}">
+        <p14:creationId xmlns:p14="http://schemas.microsoft.com/office/powerpoint/2010/main" val="1795155672"/>
+      </p:ext>
+    </p:extLst>
+  </p:cSld>
+  <p:clrMapOvr>
+    <a:masterClrMapping/>
+  </p:clrMapOvr>
+</p:sld>
+</file>
+
+<file path=ppt/slides/slide14.xml><?xml version="1.0" encoding="utf-8"?>
+<p:sld xmlns:a="http://schemas.openxmlformats.org/drawingml/2006/main" xmlns:r="http://schemas.openxmlformats.org/officeDocument/2006/relationships" xmlns:p="http://schemas.openxmlformats.org/presentationml/2006/main">
+  <p:cSld>
+    <p:bg>
+      <p:bgPr>
+        <a:solidFill>
+          <a:srgbClr val="FFF9F3"/>
+        </a:solidFill>
+        <a:effectLst/>
+      </p:bgPr>
+    </p:bg>
+    <p:spTree>
+      <p:nvGrpSpPr>
+        <p:cNvPr id="1" name="">
+          <a:extLst>
+            <a:ext uri="{FF2B5EF4-FFF2-40B4-BE49-F238E27FC236}">
+              <a16:creationId xmlns:a16="http://schemas.microsoft.com/office/drawing/2014/main" id="{CB5AFF55-802F-720C-77E8-80D1C844B9C9}"/>
+            </a:ext>
+          </a:extLst>
+        </p:cNvPr>
+        <p:cNvGrpSpPr/>
+        <p:nvPr/>
+      </p:nvGrpSpPr>
+      <p:grpSpPr>
+        <a:xfrm>
+          <a:off x="0" y="0"/>
+          <a:ext cx="0" cy="0"/>
+          <a:chOff x="0" y="0"/>
+          <a:chExt cx="0" cy="0"/>
+        </a:xfrm>
+      </p:grpSpPr>
+      <p:sp>
+        <p:nvSpPr>
+          <p:cNvPr id="2" name="TextBox 1">
+            <a:extLst>
+              <a:ext uri="{FF2B5EF4-FFF2-40B4-BE49-F238E27FC236}">
+                <a16:creationId xmlns:a16="http://schemas.microsoft.com/office/drawing/2014/main" id="{8E687B91-2B6D-DF13-D353-ABF7501E8B6D}"/>
+              </a:ext>
+            </a:extLst>
+          </p:cNvPr>
+          <p:cNvSpPr txBox="1"/>
+          <p:nvPr/>
+        </p:nvSpPr>
+        <p:spPr>
+          <a:xfrm>
+            <a:off x="731520" y="365760"/>
+            <a:ext cx="10698480" cy="365760"/>
+          </a:xfrm>
+          <a:prstGeom prst="rect">
+            <a:avLst/>
+          </a:prstGeom>
+          <a:noFill/>
+        </p:spPr>
+        <p:txBody>
+          <a:bodyPr wrap="none">
+            <a:spAutoFit/>
+          </a:bodyPr>
+          <a:lstStyle/>
+          <a:p>
+            <a:pPr marL="0" marR="0" lvl="0" indent="0" algn="l" defTabSz="457200" rtl="0" eaLnBrk="1" fontAlgn="auto" latinLnBrk="0" hangingPunct="1">
+              <a:lnSpc>
+                <a:spcPct val="100000"/>
+              </a:lnSpc>
+              <a:spcBef>
+                <a:spcPts val="0"/>
+              </a:spcBef>
+              <a:spcAft>
+                <a:spcPts val="0"/>
+              </a:spcAft>
+              <a:buClrTx/>
+              <a:buSzTx/>
+              <a:buFontTx/>
+              <a:buNone/>
+              <a:tabLst/>
+              <a:defRPr sz="1000" b="1">
+                <a:solidFill>
+                  <a:srgbClr val="B86B77"/>
+                </a:solidFill>
+              </a:defRPr>
+            </a:pPr>
+            <a:r>
+              <a:rPr kumimoji="0" sz="1000" b="1" i="0" u="none" strike="noStrike" kern="1200" cap="none" spc="0" normalizeH="0" baseline="0" noProof="0">
+                <a:ln>
+                  <a:noFill/>
+                </a:ln>
+                <a:solidFill>
+                  <a:srgbClr val="B86B77"/>
+                </a:solidFill>
+                <a:effectLst/>
+                <a:uLnTx/>
+                <a:uFillTx/>
+                <a:latin typeface="Calibri"/>
+                <a:ea typeface="+mn-ea"/>
+                <a:cs typeface="+mn-cs"/>
+              </a:rPr>
+              <a:t>SOFTWARE ENGINEERING MINI-PROJECT</a:t>
+            </a:r>
+          </a:p>
+        </p:txBody>
+      </p:sp>
+      <p:sp>
+        <p:nvSpPr>
+          <p:cNvPr id="3" name="TextBox 2">
+            <a:extLst>
+              <a:ext uri="{FF2B5EF4-FFF2-40B4-BE49-F238E27FC236}">
+                <a16:creationId xmlns:a16="http://schemas.microsoft.com/office/drawing/2014/main" id="{B6BB566D-3A90-1B0F-713A-3399F3CBA01C}"/>
+              </a:ext>
+            </a:extLst>
+          </p:cNvPr>
+          <p:cNvSpPr txBox="1"/>
+          <p:nvPr/>
+        </p:nvSpPr>
+        <p:spPr>
+          <a:xfrm>
+            <a:off x="731520" y="640080"/>
+            <a:ext cx="10698480" cy="731520"/>
+          </a:xfrm>
+          <a:prstGeom prst="rect">
+            <a:avLst/>
+          </a:prstGeom>
+          <a:noFill/>
+        </p:spPr>
+        <p:txBody>
+          <a:bodyPr wrap="none">
+            <a:spAutoFit/>
+          </a:bodyPr>
+          <a:lstStyle/>
+          <a:p>
+            <a:pPr marL="0" marR="0" lvl="0" indent="0" algn="l" defTabSz="457200" rtl="0" eaLnBrk="1" fontAlgn="auto" latinLnBrk="0" hangingPunct="1">
+              <a:lnSpc>
+                <a:spcPct val="100000"/>
+              </a:lnSpc>
+              <a:spcBef>
+                <a:spcPts val="0"/>
+              </a:spcBef>
+              <a:spcAft>
+                <a:spcPts val="0"/>
+              </a:spcAft>
+              <a:buClrTx/>
+              <a:buSzTx/>
+              <a:buFontTx/>
+              <a:buNone/>
+              <a:tabLst/>
+              <a:defRPr sz="2400" b="1">
+                <a:solidFill>
+                  <a:srgbClr val="493F3A"/>
+                </a:solidFill>
+              </a:defRPr>
+            </a:pPr>
+            <a:r>
+              <a:rPr kumimoji="0" sz="2400" b="1" i="0" u="none" strike="noStrike" kern="1200" cap="none" spc="0" normalizeH="0" baseline="0" noProof="0">
+                <a:ln>
+                  <a:noFill/>
+                </a:ln>
+                <a:solidFill>
+                  <a:srgbClr val="493F3A"/>
+                </a:solidFill>
+                <a:effectLst/>
+                <a:uLnTx/>
+                <a:uFillTx/>
+                <a:latin typeface="Calibri"/>
+                <a:ea typeface="+mn-ea"/>
+                <a:cs typeface="+mn-cs"/>
+              </a:rPr>
+              <a:t>Conclusion &amp; Academic References</a:t>
+            </a:r>
+          </a:p>
+        </p:txBody>
+      </p:sp>
+      <p:sp>
+        <p:nvSpPr>
+          <p:cNvPr id="4" name="TextBox 3">
+            <a:extLst>
+              <a:ext uri="{FF2B5EF4-FFF2-40B4-BE49-F238E27FC236}">
+                <a16:creationId xmlns:a16="http://schemas.microsoft.com/office/drawing/2014/main" id="{A610D46B-8578-F4CB-2379-34164FC8C3AD}"/>
+              </a:ext>
+            </a:extLst>
+          </p:cNvPr>
+          <p:cNvSpPr txBox="1"/>
+          <p:nvPr/>
+        </p:nvSpPr>
+        <p:spPr>
+          <a:xfrm>
+            <a:off x="458142" y="1737360"/>
+            <a:ext cx="10698480" cy="261610"/>
+          </a:xfrm>
+          <a:prstGeom prst="rect">
+            <a:avLst/>
+          </a:prstGeom>
+          <a:noFill/>
+        </p:spPr>
+        <p:txBody>
+          <a:bodyPr wrap="square">
+            <a:spAutoFit/>
+          </a:bodyPr>
+          <a:lstStyle/>
+          <a:p>
+            <a:pPr marL="0" marR="0" lvl="0" indent="0" algn="l" defTabSz="457200" rtl="0" eaLnBrk="1" fontAlgn="auto" latinLnBrk="0" hangingPunct="1">
+              <a:lnSpc>
+                <a:spcPct val="100000"/>
+              </a:lnSpc>
+              <a:spcBef>
+                <a:spcPts val="0"/>
+              </a:spcBef>
+              <a:spcAft>
+                <a:spcPts val="0"/>
+              </a:spcAft>
+              <a:buClrTx/>
+              <a:buSzTx/>
+              <a:buFontTx/>
+              <a:buNone/>
+              <a:tabLst/>
+              <a:defRPr sz="1500" b="1">
+                <a:solidFill>
+                  <a:srgbClr val="4A6B53"/>
+                </a:solidFill>
+              </a:defRPr>
+            </a:pPr>
+            <a:endParaRPr kumimoji="0" sz="1100" b="0" i="0" u="none" strike="noStrike" kern="1200" cap="none" spc="0" normalizeH="0" baseline="0" noProof="0" dirty="0">
+              <a:ln>
+                <a:noFill/>
+              </a:ln>
+              <a:solidFill>
+                <a:srgbClr val="493F3A"/>
+              </a:solidFill>
+              <a:effectLst/>
+              <a:uLnTx/>
+              <a:uFillTx/>
+              <a:latin typeface="Calibri"/>
+              <a:ea typeface="+mn-ea"/>
+              <a:cs typeface="+mn-cs"/>
+            </a:endParaRPr>
+          </a:p>
+        </p:txBody>
+      </p:sp>
+      <p:pic>
+        <p:nvPicPr>
+          <p:cNvPr id="7" name="Picture 6">
+            <a:extLst>
+              <a:ext uri="{FF2B5EF4-FFF2-40B4-BE49-F238E27FC236}">
+                <a16:creationId xmlns:a16="http://schemas.microsoft.com/office/drawing/2014/main" id="{9441CA7C-FEF4-789D-9F04-4CF7127F8DAE}"/>
+              </a:ext>
+            </a:extLst>
+          </p:cNvPr>
+          <p:cNvPicPr>
+            <a:picLocks noChangeAspect="1"/>
+          </p:cNvPicPr>
+          <p:nvPr/>
+        </p:nvPicPr>
+        <p:blipFill>
+          <a:blip r:embed="rId2"/>
+          <a:stretch>
+            <a:fillRect/>
+          </a:stretch>
+        </p:blipFill>
+        <p:spPr>
+          <a:xfrm>
+            <a:off x="221316" y="0"/>
+            <a:ext cx="11749367" cy="6858000"/>
+          </a:xfrm>
+          <a:prstGeom prst="rect">
+            <a:avLst/>
+          </a:prstGeom>
+        </p:spPr>
+      </p:pic>
+    </p:spTree>
+    <p:extLst>
+      <p:ext uri="{BB962C8B-B14F-4D97-AF65-F5344CB8AC3E}">
+        <p14:creationId xmlns:p14="http://schemas.microsoft.com/office/powerpoint/2010/main" val="3094979506"/>
+      </p:ext>
+    </p:extLst>
+  </p:cSld>
+  <p:clrMapOvr>
+    <a:masterClrMapping/>
+  </p:clrMapOvr>
+</p:sld>
+</file>
+
 <file path=ppt/slides/slide2.xml><?xml version="1.0" encoding="utf-8"?>
-<p:sld xmlns:a="http://schemas.openxmlformats.org/drawingml/2006/main" xmlns:p="http://schemas.openxmlformats.org/presentationml/2006/main" xmlns:r="http://schemas.openxmlformats.org/officeDocument/2006/relationships">
+<p:sld xmlns:a="http://schemas.openxmlformats.org/drawingml/2006/main" xmlns:r="http://schemas.openxmlformats.org/officeDocument/2006/relationships" xmlns:p="http://schemas.openxmlformats.org/presentationml/2006/main">
   <p:cSld>
     <p:bg>
       <p:bgPr>
@@ -3851,7 +4436,14 @@
         <p:cNvGrpSpPr/>
         <p:nvPr/>
       </p:nvGrpSpPr>
-      <p:grpSpPr/>
+      <p:grpSpPr>
+        <a:xfrm>
+          <a:off x="0" y="0"/>
+          <a:ext cx="0" cy="0"/>
+          <a:chOff x="0" y="0"/>
+          <a:chExt cx="0" cy="0"/>
+        </a:xfrm>
+      </p:grpSpPr>
       <p:sp>
         <p:nvSpPr>
           <p:cNvPr id="2" name="TextBox 1"/>
@@ -3943,13 +4535,15 @@
             <a:spAutoFit/>
           </a:bodyPr>
           <a:lstStyle/>
-          <a:p/>
+          <a:p>
+            <a:endParaRPr/>
+          </a:p>
           <a:p>
             <a:pPr>
               <a:spcAft>
                 <a:spcPts val="1400"/>
               </a:spcAft>
-              <a:defRPr b="1" sz="1400">
+              <a:defRPr sz="1400" b="1">
                 <a:solidFill>
                   <a:srgbClr val="493F3A"/>
                 </a:solidFill>
@@ -3959,7 +4553,7 @@
               <a:t>•  Clinical Need &amp; Early Screening: </a:t>
             </a:r>
             <a:r>
-              <a:rPr b="0" sz="1300"/>
+              <a:rPr sz="1300" b="0"/>
               <a:t>Skin malignancies (melanoma, basal cell carcinoma, actinic keratoses) carry dramatically higher survival rates when detected early. However, access to board-certified dermatologists is constrained in primary healthcare and rural regions.</a:t>
             </a:r>
           </a:p>
@@ -3968,7 +4562,7 @@
               <a:spcAft>
                 <a:spcPts val="1400"/>
               </a:spcAft>
-              <a:defRPr b="1" sz="1400">
+              <a:defRPr sz="1400" b="1">
                 <a:solidFill>
                   <a:srgbClr val="493F3A"/>
                 </a:solidFill>
@@ -3978,7 +4572,7 @@
               <a:t>•  Computer Vision Potential: </a:t>
             </a:r>
             <a:r>
-              <a:rPr b="0" sz="1300"/>
+              <a:rPr sz="1300" b="0"/>
               <a:t>Convolutional Neural Networks (CNNs) excel at extracting subtle spatial textures, pigment networks, and border irregularities from dermoscopic lesion photography.</a:t>
             </a:r>
           </a:p>
@@ -3987,7 +4581,7 @@
               <a:spcAft>
                 <a:spcPts val="1400"/>
               </a:spcAft>
-              <a:defRPr b="1" sz="1400">
+              <a:defRPr sz="1400" b="1">
                 <a:solidFill>
                   <a:srgbClr val="493F3A"/>
                 </a:solidFill>
@@ -3997,7 +4591,7 @@
               <a:t>•  End-to-End Software Engineering: </a:t>
             </a:r>
             <a:r>
-              <a:rPr b="0" sz="1300"/>
+              <a:rPr sz="1300" b="0"/>
               <a:t>Bridging research prototypes into real-world utility requires a secure, responsive, and ethical web application with robust authentication, defensive image validation, persistent database storage, and role-based access control.</a:t>
             </a:r>
           </a:p>
@@ -4006,7 +4600,7 @@
               <a:spcAft>
                 <a:spcPts val="1400"/>
               </a:spcAft>
-              <a:defRPr b="1" sz="1400">
+              <a:defRPr sz="1400" b="1">
                 <a:solidFill>
                   <a:srgbClr val="493F3A"/>
                 </a:solidFill>
@@ -4016,7 +4610,7 @@
               <a:t>•  Academic Research Scope: </a:t>
             </a:r>
             <a:r>
-              <a:rPr b="0" sz="1300"/>
+              <a:rPr sz="1300" b="0"/>
               <a:t>Engineered as an academic educational screening platform. Strictly non-diagnostic; enforces prominent medical disclaimers to ensure responsible user guidance.</a:t>
             </a:r>
           </a:p>
@@ -4031,7 +4625,7 @@
 </file>
 
 <file path=ppt/slides/slide3.xml><?xml version="1.0" encoding="utf-8"?>
-<p:sld xmlns:a="http://schemas.openxmlformats.org/drawingml/2006/main" xmlns:p="http://schemas.openxmlformats.org/presentationml/2006/main" xmlns:r="http://schemas.openxmlformats.org/officeDocument/2006/relationships">
+<p:sld xmlns:a="http://schemas.openxmlformats.org/drawingml/2006/main" xmlns:r="http://schemas.openxmlformats.org/officeDocument/2006/relationships" xmlns:p="http://schemas.openxmlformats.org/presentationml/2006/main">
   <p:cSld>
     <p:bg>
       <p:bgPr>
@@ -4047,7 +4641,14 @@
         <p:cNvGrpSpPr/>
         <p:nvPr/>
       </p:nvGrpSpPr>
-      <p:grpSpPr/>
+      <p:grpSpPr>
+        <a:xfrm>
+          <a:off x="0" y="0"/>
+          <a:ext cx="0" cy="0"/>
+          <a:chOff x="0" y="0"/>
+          <a:chExt cx="0" cy="0"/>
+        </a:xfrm>
+      </p:grpSpPr>
       <p:sp>
         <p:nvSpPr>
           <p:cNvPr id="2" name="TextBox 1"/>
@@ -4141,7 +4742,7 @@
           <a:lstStyle/>
           <a:p>
             <a:pPr>
-              <a:defRPr b="1" sz="1500">
+              <a:defRPr sz="1500" b="1">
                 <a:solidFill>
                   <a:srgbClr val="B86B77"/>
                 </a:solidFill>
@@ -4164,7 +4765,7 @@
           </a:p>
           <a:p>
             <a:pPr>
-              <a:defRPr b="1" sz="1500">
+              <a:defRPr sz="1500" b="1">
                 <a:solidFill>
                   <a:srgbClr val="4A6B53"/>
                 </a:solidFill>
@@ -4245,7 +4846,7 @@
 </file>
 
 <file path=ppt/slides/slide4.xml><?xml version="1.0" encoding="utf-8"?>
-<p:sld xmlns:a="http://schemas.openxmlformats.org/drawingml/2006/main" xmlns:p="http://schemas.openxmlformats.org/presentationml/2006/main" xmlns:r="http://schemas.openxmlformats.org/officeDocument/2006/relationships">
+<p:sld xmlns:a="http://schemas.openxmlformats.org/drawingml/2006/main" xmlns:r="http://schemas.openxmlformats.org/officeDocument/2006/relationships" xmlns:p="http://schemas.openxmlformats.org/presentationml/2006/main">
   <p:cSld>
     <p:bg>
       <p:bgPr>
@@ -4261,7 +4862,14 @@
         <p:cNvGrpSpPr/>
         <p:nvPr/>
       </p:nvGrpSpPr>
-      <p:grpSpPr/>
+      <p:grpSpPr>
+        <a:xfrm>
+          <a:off x="0" y="0"/>
+          <a:ext cx="0" cy="0"/>
+          <a:chOff x="0" y="0"/>
+          <a:chExt cx="0" cy="0"/>
+        </a:xfrm>
+      </p:grpSpPr>
       <p:sp>
         <p:nvSpPr>
           <p:cNvPr id="2" name="TextBox 1"/>
@@ -4353,13 +4961,15 @@
             <a:spAutoFit/>
           </a:bodyPr>
           <a:lstStyle/>
-          <a:p/>
+          <a:p>
+            <a:endParaRPr/>
+          </a:p>
           <a:p>
             <a:pPr>
               <a:spcAft>
                 <a:spcPts val="1200"/>
               </a:spcAft>
-              <a:defRPr b="1" sz="1400">
+              <a:defRPr sz="1400" b="1">
                 <a:solidFill>
                   <a:srgbClr val="493F3A"/>
                 </a:solidFill>
@@ -4369,7 +4979,7 @@
               <a:t>•  Presentation Layer (Frontend): </a:t>
             </a:r>
             <a:r>
-              <a:rPr b="0" sz="1300"/>
+              <a:rPr sz="1300" b="0"/>
               <a:t>HTML5, CSS3, JavaScript. Calming pastel healthcare aesthetic (blush pink #F4DDE2, warm beige #F5EBDD, sage green #DCE8D5). Fully mobile-responsive.</a:t>
             </a:r>
           </a:p>
@@ -4378,7 +4988,7 @@
               <a:spcAft>
                 <a:spcPts val="1200"/>
               </a:spcAft>
-              <a:defRPr b="1" sz="1400">
+              <a:defRPr sz="1400" b="1">
                 <a:solidFill>
                   <a:srgbClr val="493F3A"/>
                 </a:solidFill>
@@ -4388,7 +4998,7 @@
               <a:t>•  Application &amp; Web Layer (Backend): </a:t>
             </a:r>
             <a:r>
-              <a:rPr b="0" sz="1300"/>
+              <a:rPr sz="1300" b="0"/>
               <a:t>Python 3.13 + Flask microframework. Structured with 5 modular blueprints: auth_bp, main_bp, analysis_bp, testing_bp, admin_bp.</a:t>
             </a:r>
           </a:p>
@@ -4397,7 +5007,7 @@
               <a:spcAft>
                 <a:spcPts val="1200"/>
               </a:spcAft>
-              <a:defRPr b="1" sz="1400">
+              <a:defRPr sz="1400" b="1">
                 <a:solidFill>
                   <a:srgbClr val="493F3A"/>
                 </a:solidFill>
@@ -4407,7 +5017,7 @@
               <a:t>•  Deep Learning &amp; Computer Vision: </a:t>
             </a:r>
             <a:r>
-              <a:rPr b="0" sz="1300"/>
+              <a:rPr sz="1300" b="0"/>
               <a:t>TensorFlow 2.21 + Keras 3.15 + OpenCV + Pillow + NumPy. MobileNetV2 architecture with transfer learning specialized for 7 HAM10000 classes.</a:t>
             </a:r>
           </a:p>
@@ -4416,7 +5026,7 @@
               <a:spcAft>
                 <a:spcPts val="1200"/>
               </a:spcAft>
-              <a:defRPr b="1" sz="1400">
+              <a:defRPr sz="1400" b="1">
                 <a:solidFill>
                   <a:srgbClr val="493F3A"/>
                 </a:solidFill>
@@ -4426,7 +5036,7 @@
               <a:t>•  Data Persistence &amp; Clinical Reporting: </a:t>
             </a:r>
             <a:r>
-              <a:rPr b="0" sz="1300"/>
+              <a:rPr sz="1300" b="0"/>
               <a:t>SQLite isolated relational database (instance/skin_cancer.db) + ReportLab PDF generation engine synthesizing multi-page screening summaries.</a:t>
             </a:r>
           </a:p>
@@ -4435,7 +5045,7 @@
               <a:spcAft>
                 <a:spcPts val="1200"/>
               </a:spcAft>
-              <a:defRPr b="1" sz="1400">
+              <a:defRPr sz="1400" b="1">
                 <a:solidFill>
                   <a:srgbClr val="493F3A"/>
                 </a:solidFill>
@@ -4445,7 +5055,7 @@
               <a:t>•  Automated Quality Assurance: </a:t>
             </a:r>
             <a:r>
-              <a:rPr b="0" sz="1300"/>
+              <a:rPr sz="1300" b="0"/>
               <a:t>Pytest test framework with 21 unit, functional, security, and integration tests.</a:t>
             </a:r>
           </a:p>
@@ -4460,7 +5070,7 @@
 </file>
 
 <file path=ppt/slides/slide5.xml><?xml version="1.0" encoding="utf-8"?>
-<p:sld xmlns:a="http://schemas.openxmlformats.org/drawingml/2006/main" xmlns:p="http://schemas.openxmlformats.org/presentationml/2006/main" xmlns:r="http://schemas.openxmlformats.org/officeDocument/2006/relationships">
+<p:sld xmlns:a="http://schemas.openxmlformats.org/drawingml/2006/main" xmlns:r="http://schemas.openxmlformats.org/officeDocument/2006/relationships" xmlns:p="http://schemas.openxmlformats.org/presentationml/2006/main">
   <p:cSld>
     <p:bg>
       <p:bgPr>
@@ -4476,7 +5086,14 @@
         <p:cNvGrpSpPr/>
         <p:nvPr/>
       </p:nvGrpSpPr>
-      <p:grpSpPr/>
+      <p:grpSpPr>
+        <a:xfrm>
+          <a:off x="0" y="0"/>
+          <a:ext cx="0" cy="0"/>
+          <a:chOff x="0" y="0"/>
+          <a:chExt cx="0" cy="0"/>
+        </a:xfrm>
+      </p:grpSpPr>
       <p:sp>
         <p:nvSpPr>
           <p:cNvPr id="2" name="TextBox 1"/>
@@ -4568,13 +5185,15 @@
             <a:spAutoFit/>
           </a:bodyPr>
           <a:lstStyle/>
-          <a:p/>
+          <a:p>
+            <a:endParaRPr/>
+          </a:p>
           <a:p>
             <a:pPr>
               <a:spcAft>
                 <a:spcPts val="1200"/>
               </a:spcAft>
-              <a:defRPr b="1" sz="1400">
+              <a:defRPr sz="1400" b="1">
                 <a:solidFill>
                   <a:srgbClr val="493F3A"/>
                 </a:solidFill>
@@ -4584,7 +5203,7 @@
               <a:t>•  Primary Dataset: </a:t>
             </a:r>
             <a:r>
-              <a:rPr b="0" sz="1300"/>
+              <a:rPr sz="1300" b="0"/>
               <a:t>HAM10000 ('Human Against Machine with 10,000 training images') dermatoscopic collection, acquired via the official ISIC Archive.</a:t>
             </a:r>
           </a:p>
@@ -4593,7 +5212,7 @@
               <a:spcAft>
                 <a:spcPts val="1200"/>
               </a:spcAft>
-              <a:defRPr b="1" sz="1400">
+              <a:defRPr sz="1400" b="1">
                 <a:solidFill>
                   <a:srgbClr val="493F3A"/>
                 </a:solidFill>
@@ -4603,7 +5222,7 @@
               <a:t>•  7 Diagnostic Categories: </a:t>
             </a:r>
             <a:r>
-              <a:rPr b="0" sz="1300"/>
+              <a:rPr sz="1300" b="0"/>
               <a:t>Actinic Keratoses (akiec), Basal Cell Carcinoma (bcc), Benign Keratosis-like (bkl), Dermatofibroma (df), Melanoma (mel), Melanocytic Nevi (nv), Vascular Lesions (vasc).</a:t>
             </a:r>
           </a:p>
@@ -4612,7 +5231,7 @@
               <a:spcAft>
                 <a:spcPts val="1200"/>
               </a:spcAft>
-              <a:defRPr b="1" sz="1400">
+              <a:defRPr sz="1400" b="1">
                 <a:solidFill>
                   <a:srgbClr val="493F3A"/>
                 </a:solidFill>
@@ -4622,7 +5241,7 @@
               <a:t>•  Defensive Preprocessing: </a:t>
             </a:r>
             <a:r>
-              <a:rPr b="0" sz="1300"/>
+              <a:rPr sz="1300" b="0"/>
               <a:t>Strict dimension checks (50x50 to 6000x6000), Pillow format verification, RGB conversion, aspect ratio checks, and standard 224x224 normalization for MobileNetV2.</a:t>
             </a:r>
           </a:p>
@@ -4631,7 +5250,7 @@
               <a:spcAft>
                 <a:spcPts val="1200"/>
               </a:spcAft>
-              <a:defRPr b="1" sz="1400">
+              <a:defRPr sz="1400" b="1">
                 <a:solidFill>
                   <a:srgbClr val="493F3A"/>
                 </a:solidFill>
@@ -4641,7 +5260,7 @@
               <a:t>•  Leakage Prevention: </a:t>
             </a:r>
             <a:r>
-              <a:rPr b="0" sz="1300"/>
+              <a:rPr sz="1300" b="0"/>
               <a:t>Lesion-level grouping (lesion_id) ensures that multiple photographs of the same anatomical lesion never cross between training, validation, and held-out test splits.</a:t>
             </a:r>
           </a:p>
@@ -4656,7 +5275,7 @@
 </file>
 
 <file path=ppt/slides/slide6.xml><?xml version="1.0" encoding="utf-8"?>
-<p:sld xmlns:a="http://schemas.openxmlformats.org/drawingml/2006/main" xmlns:p="http://schemas.openxmlformats.org/presentationml/2006/main" xmlns:r="http://schemas.openxmlformats.org/officeDocument/2006/relationships">
+<p:sld xmlns:a="http://schemas.openxmlformats.org/drawingml/2006/main" xmlns:r="http://schemas.openxmlformats.org/officeDocument/2006/relationships" xmlns:p="http://schemas.openxmlformats.org/presentationml/2006/main">
   <p:cSld>
     <p:bg>
       <p:bgPr>
@@ -4672,7 +5291,14 @@
         <p:cNvGrpSpPr/>
         <p:nvPr/>
       </p:nvGrpSpPr>
-      <p:grpSpPr/>
+      <p:grpSpPr>
+        <a:xfrm>
+          <a:off x="0" y="0"/>
+          <a:ext cx="0" cy="0"/>
+          <a:chOff x="0" y="0"/>
+          <a:chExt cx="0" cy="0"/>
+        </a:xfrm>
+      </p:grpSpPr>
       <p:sp>
         <p:nvSpPr>
           <p:cNvPr id="2" name="TextBox 1"/>
@@ -4764,13 +5390,15 @@
             <a:spAutoFit/>
           </a:bodyPr>
           <a:lstStyle/>
-          <a:p/>
+          <a:p>
+            <a:endParaRPr/>
+          </a:p>
           <a:p>
             <a:pPr>
               <a:spcAft>
                 <a:spcPts val="1200"/>
               </a:spcAft>
-              <a:defRPr b="1" sz="1400">
+              <a:defRPr sz="1400" b="1">
                 <a:solidFill>
                   <a:srgbClr val="493F3A"/>
                 </a:solidFill>
@@ -4780,7 +5408,7 @@
               <a:t>•  Base Architecture: </a:t>
             </a:r>
             <a:r>
-              <a:rPr b="0" sz="1300"/>
+              <a:rPr sz="1300" b="0"/>
               <a:t>MobileNetV2 pre-trained on ImageNet. Utilizes depthwise separable convolutions and inverted residual bottleneck blocks for lightweight, low-latency inference.</a:t>
             </a:r>
           </a:p>
@@ -4789,7 +5417,7 @@
               <a:spcAft>
                 <a:spcPts val="1200"/>
               </a:spcAft>
-              <a:defRPr b="1" sz="1400">
+              <a:defRPr sz="1400" b="1">
                 <a:solidFill>
                   <a:srgbClr val="493F3A"/>
                 </a:solidFill>
@@ -4799,7 +5427,7 @@
               <a:t>•  Transfer Learning Custom Head: </a:t>
             </a:r>
             <a:r>
-              <a:rPr b="0" sz="1300"/>
+              <a:rPr sz="1300" b="0"/>
               <a:t>GlobalAveragePooling2D -&gt; BatchNormalization -&gt; Dense(128, ReLU) -&gt; Dropout(0.40) -&gt; Dense(7, Softmax).</a:t>
             </a:r>
           </a:p>
@@ -4808,7 +5436,7 @@
               <a:spcAft>
                 <a:spcPts val="1200"/>
               </a:spcAft>
-              <a:defRPr b="1" sz="1400">
+              <a:defRPr sz="1400" b="1">
                 <a:solidFill>
                   <a:srgbClr val="493F3A"/>
                 </a:solidFill>
@@ -4818,7 +5446,7 @@
               <a:t>•  Class Imbalance Strategy: </a:t>
             </a:r>
             <a:r>
-              <a:rPr b="0" sz="1300"/>
+              <a:rPr sz="1300" b="0"/>
               <a:t>Balanced class weights computed dynamically across under-represented malignant categories (mel, bcc, akiec) vs majority benign moles (nv).</a:t>
             </a:r>
           </a:p>
@@ -4827,7 +5455,7 @@
               <a:spcAft>
                 <a:spcPts val="1200"/>
               </a:spcAft>
-              <a:defRPr b="1" sz="1400">
+              <a:defRPr sz="1400" b="1">
                 <a:solidFill>
                   <a:srgbClr val="493F3A"/>
                 </a:solidFill>
@@ -4837,7 +5465,7 @@
               <a:t>•  Inference Execution: </a:t>
             </a:r>
             <a:r>
-              <a:rPr b="0" sz="1300"/>
+              <a:rPr sz="1300" b="0"/>
               <a:t>Live Python service (model_service.py) transforms incoming PIL images, executes model.predict(), maps softmax outputs across all 7 diagnostic classes, and computes risk stratification.</a:t>
             </a:r>
           </a:p>
@@ -4852,7 +5480,7 @@
 </file>
 
 <file path=ppt/slides/slide7.xml><?xml version="1.0" encoding="utf-8"?>
-<p:sld xmlns:a="http://schemas.openxmlformats.org/drawingml/2006/main" xmlns:p="http://schemas.openxmlformats.org/presentationml/2006/main" xmlns:r="http://schemas.openxmlformats.org/officeDocument/2006/relationships">
+<p:sld xmlns:a="http://schemas.openxmlformats.org/drawingml/2006/main" xmlns:r="http://schemas.openxmlformats.org/officeDocument/2006/relationships" xmlns:p="http://schemas.openxmlformats.org/presentationml/2006/main">
   <p:cSld>
     <p:bg>
       <p:bgPr>
@@ -4868,7 +5496,14 @@
         <p:cNvGrpSpPr/>
         <p:nvPr/>
       </p:nvGrpSpPr>
-      <p:grpSpPr/>
+      <p:grpSpPr>
+        <a:xfrm>
+          <a:off x="0" y="0"/>
+          <a:ext cx="0" cy="0"/>
+          <a:chOff x="0" y="0"/>
+          <a:chExt cx="0" cy="0"/>
+        </a:xfrm>
+      </p:grpSpPr>
       <p:sp>
         <p:nvSpPr>
           <p:cNvPr id="2" name="TextBox 1"/>
@@ -4960,13 +5595,15 @@
             <a:spAutoFit/>
           </a:bodyPr>
           <a:lstStyle/>
-          <a:p/>
+          <a:p>
+            <a:endParaRPr/>
+          </a:p>
           <a:p>
             <a:pPr>
               <a:spcAft>
                 <a:spcPts val="1200"/>
               </a:spcAft>
-              <a:defRPr b="1" sz="1400">
+              <a:defRPr sz="1400" b="1">
                 <a:solidFill>
                   <a:srgbClr val="493F3A"/>
                 </a:solidFill>
@@ -4976,7 +5613,7 @@
               <a:t>•  Authentication &amp; Password Storage: </a:t>
             </a:r>
             <a:r>
-              <a:rPr b="0" sz="1300"/>
+              <a:rPr sz="1300" b="0"/>
               <a:t>User passwords hashed using the cryptographic scrypt algorithm. Sessions securely managed; supports flexible login via email or unique username.</a:t>
             </a:r>
           </a:p>
@@ -4985,7 +5622,7 @@
               <a:spcAft>
                 <a:spcPts val="1200"/>
               </a:spcAft>
-              <a:defRPr b="1" sz="1400">
+              <a:defRPr sz="1400" b="1">
                 <a:solidFill>
                   <a:srgbClr val="493F3A"/>
                 </a:solidFill>
@@ -4995,7 +5632,7 @@
               <a:t>•  Role-Based Access Control (RBAC): </a:t>
             </a:r>
             <a:r>
-              <a:rPr b="0" sz="1300"/>
+              <a:rPr sz="1300" b="0"/>
               <a:t>Users partitioned into patient, physician, and admin roles. The @admin_required decorator protects administrative routes, issuing HTTP 403 Forbidden for unauthorized roles.</a:t>
             </a:r>
           </a:p>
@@ -5004,7 +5641,7 @@
               <a:spcAft>
                 <a:spcPts val="1200"/>
               </a:spcAft>
-              <a:defRPr b="1" sz="1400">
+              <a:defRPr sz="1400" b="1">
                 <a:solidFill>
                   <a:srgbClr val="493F3A"/>
                 </a:solidFill>
@@ -5014,7 +5651,7 @@
               <a:t>•  Administrator Command Center (/admin): </a:t>
             </a:r>
             <a:r>
-              <a:rPr b="0" sz="1300"/>
+              <a:rPr sz="1300" b="0"/>
               <a:t>Dedicated surveillance console tracking deep learning model telemetry, file storage statistics, user roster (read-only; no password hashes exposed), and global screening logs.</a:t>
             </a:r>
           </a:p>
@@ -5023,7 +5660,7 @@
               <a:spcAft>
                 <a:spcPts val="1200"/>
               </a:spcAft>
-              <a:defRPr b="1" sz="1400">
+              <a:defRPr sz="1400" b="1">
                 <a:solidFill>
                   <a:srgbClr val="493F3A"/>
                 </a:solidFill>
@@ -5033,7 +5670,7 @@
               <a:t>•  Patient Data Isolation: </a:t>
             </a:r>
             <a:r>
-              <a:rPr b="0" sz="1300"/>
+              <a:rPr sz="1300" b="0"/>
               <a:t>Strict per-user query scoping ensures patient records, uploaded dermoscopic imagery, and PDF screening reports cannot be accessed or downloaded across different accounts.</a:t>
             </a:r>
           </a:p>
@@ -5048,7 +5685,7 @@
 </file>
 
 <file path=ppt/slides/slide8.xml><?xml version="1.0" encoding="utf-8"?>
-<p:sld xmlns:a="http://schemas.openxmlformats.org/drawingml/2006/main" xmlns:p="http://schemas.openxmlformats.org/presentationml/2006/main" xmlns:r="http://schemas.openxmlformats.org/officeDocument/2006/relationships">
+<p:sld xmlns:a="http://schemas.openxmlformats.org/drawingml/2006/main" xmlns:r="http://schemas.openxmlformats.org/officeDocument/2006/relationships" xmlns:p="http://schemas.openxmlformats.org/presentationml/2006/main">
   <p:cSld>
     <p:bg>
       <p:bgPr>
@@ -5064,7 +5701,14 @@
         <p:cNvGrpSpPr/>
         <p:nvPr/>
       </p:nvGrpSpPr>
-      <p:grpSpPr/>
+      <p:grpSpPr>
+        <a:xfrm>
+          <a:off x="0" y="0"/>
+          <a:ext cx="0" cy="0"/>
+          <a:chOff x="0" y="0"/>
+          <a:chExt cx="0" cy="0"/>
+        </a:xfrm>
+      </p:grpSpPr>
       <p:sp>
         <p:nvSpPr>
           <p:cNvPr id="2" name="TextBox 1"/>
@@ -5156,13 +5800,15 @@
             <a:spAutoFit/>
           </a:bodyPr>
           <a:lstStyle/>
-          <a:p/>
+          <a:p>
+            <a:endParaRPr/>
+          </a:p>
           <a:p>
             <a:pPr>
               <a:spcAft>
                 <a:spcPts val="1200"/>
               </a:spcAft>
-              <a:defRPr b="1" sz="1400">
+              <a:defRPr sz="1400" b="1">
                 <a:solidFill>
                   <a:srgbClr val="493F3A"/>
                 </a:solidFill>
@@ -5172,7 +5818,7 @@
               <a:t>•  Automated Test Suite (21 Tests): </a:t>
             </a:r>
             <a:r>
-              <a:rPr b="0" sz="1300"/>
+              <a:rPr sz="1300" b="0"/>
               <a:t>Complete pytest test suite covering authentication (TC-01, TC-02), administrative RBAC security, image validation (TC-03), model inference, history isolation (TC-04), and test case redirects.</a:t>
             </a:r>
           </a:p>
@@ -5181,7 +5827,7 @@
               <a:spcAft>
                 <a:spcPts val="1200"/>
               </a:spcAft>
-              <a:defRPr b="1" sz="1400">
+              <a:defRPr sz="1400" b="1">
                 <a:solidFill>
                   <a:srgbClr val="493F3A"/>
                 </a:solidFill>
@@ -5191,7 +5837,7 @@
               <a:t>•  Defensive Input Rejection: </a:t>
             </a:r>
             <a:r>
-              <a:rPr b="0" sz="1300"/>
+              <a:rPr sz="1300" b="0"/>
               <a:t>Verified automatic rejection and safe error handling for non-image text files, corrupted headers, oversized payloads (&gt;10MB), and missing uploads.</a:t>
             </a:r>
           </a:p>
@@ -5200,7 +5846,7 @@
               <a:spcAft>
                 <a:spcPts val="1200"/>
               </a:spcAft>
-              <a:defRPr b="1" sz="1400">
+              <a:defRPr sz="1400" b="1">
                 <a:solidFill>
                   <a:srgbClr val="493F3A"/>
                 </a:solidFill>
@@ -5210,7 +5856,7 @@
               <a:t>•  Clean UI Architecture: </a:t>
             </a:r>
             <a:r>
-              <a:rPr b="0" sz="1300"/>
+              <a:rPr sz="1300" b="0"/>
               <a:t>Per project requirements, the internal test-case execution data is preserved in SQLite, while legacy test-case tables were cleanly retired from public navigation with seamless redirects.</a:t>
             </a:r>
           </a:p>
@@ -5219,7 +5865,7 @@
               <a:spcAft>
                 <a:spcPts val="1200"/>
               </a:spcAft>
-              <a:defRPr b="1" sz="1400">
+              <a:defRPr sz="1400" b="1">
                 <a:solidFill>
                   <a:srgbClr val="493F3A"/>
                 </a:solidFill>
@@ -5229,7 +5875,7 @@
               <a:t>•  100% Verification Rate: </a:t>
             </a:r>
             <a:r>
-              <a:rPr b="0" sz="1300"/>
+              <a:rPr sz="1300" b="0"/>
               <a:t>All 21 automated test cases pass cleanly with zero failures or deprecation regressions.</a:t>
             </a:r>
           </a:p>
@@ -5244,7 +5890,7 @@
 </file>
 
 <file path=ppt/slides/slide9.xml><?xml version="1.0" encoding="utf-8"?>
-<p:sld xmlns:a="http://schemas.openxmlformats.org/drawingml/2006/main" xmlns:p="http://schemas.openxmlformats.org/presentationml/2006/main" xmlns:r="http://schemas.openxmlformats.org/officeDocument/2006/relationships">
+<p:sld xmlns:a="http://schemas.openxmlformats.org/drawingml/2006/main" xmlns:r="http://schemas.openxmlformats.org/officeDocument/2006/relationships" xmlns:p="http://schemas.openxmlformats.org/presentationml/2006/main">
   <p:cSld>
     <p:bg>
       <p:bgPr>
@@ -5260,7 +5906,14 @@
         <p:cNvGrpSpPr/>
         <p:nvPr/>
       </p:nvGrpSpPr>
-      <p:grpSpPr/>
+      <p:grpSpPr>
+        <a:xfrm>
+          <a:off x="0" y="0"/>
+          <a:ext cx="0" cy="0"/>
+          <a:chOff x="0" y="0"/>
+          <a:chExt cx="0" cy="0"/>
+        </a:xfrm>
+      </p:grpSpPr>
       <p:sp>
         <p:nvSpPr>
           <p:cNvPr id="2" name="TextBox 1"/>

</xml_diff>